<commit_message>
Update PDcontrol simulation parameters and trajectory generation. Adjusted motor current and simulation time, modified PD controller gains, and refined trajectory generation logic for improved performance. Added comments for clarity and removed unused code sections. Fixed calculation in deltaFK function for correct root selection.
</commit_message>
<xml_diff>
--- a/references/画图.pptx
+++ b/references/画图.pptx
@@ -6,6 +6,7 @@
   </p:sldMasterIdLst>
   <p:sldIdLst>
     <p:sldId id="256" r:id="rId2"/>
+    <p:sldId id="258" r:id="rId3"/>
   </p:sldIdLst>
   <p:sldSz cx="12192000" cy="6858000"/>
   <p:notesSz cx="6858000" cy="9144000"/>
@@ -270,7 +271,7 @@
           <a:p>
             <a:fld id="{115BA0BE-EEFE-44F5-956C-0B3C1679C7A2}" type="datetimeFigureOut">
               <a:rPr lang="zh-CN" altLang="en-US" smtClean="0"/>
-              <a:t>2025/11/17</a:t>
+              <a:t>2026/3/13</a:t>
             </a:fld>
             <a:endParaRPr lang="zh-CN" altLang="en-US"/>
           </a:p>
@@ -468,7 +469,7 @@
           <a:p>
             <a:fld id="{115BA0BE-EEFE-44F5-956C-0B3C1679C7A2}" type="datetimeFigureOut">
               <a:rPr lang="zh-CN" altLang="en-US" smtClean="0"/>
-              <a:t>2025/11/17</a:t>
+              <a:t>2026/3/13</a:t>
             </a:fld>
             <a:endParaRPr lang="zh-CN" altLang="en-US"/>
           </a:p>
@@ -676,7 +677,7 @@
           <a:p>
             <a:fld id="{115BA0BE-EEFE-44F5-956C-0B3C1679C7A2}" type="datetimeFigureOut">
               <a:rPr lang="zh-CN" altLang="en-US" smtClean="0"/>
-              <a:t>2025/11/17</a:t>
+              <a:t>2026/3/13</a:t>
             </a:fld>
             <a:endParaRPr lang="zh-CN" altLang="en-US"/>
           </a:p>
@@ -874,7 +875,7 @@
           <a:p>
             <a:fld id="{115BA0BE-EEFE-44F5-956C-0B3C1679C7A2}" type="datetimeFigureOut">
               <a:rPr lang="zh-CN" altLang="en-US" smtClean="0"/>
-              <a:t>2025/11/17</a:t>
+              <a:t>2026/3/13</a:t>
             </a:fld>
             <a:endParaRPr lang="zh-CN" altLang="en-US"/>
           </a:p>
@@ -1149,7 +1150,7 @@
           <a:p>
             <a:fld id="{115BA0BE-EEFE-44F5-956C-0B3C1679C7A2}" type="datetimeFigureOut">
               <a:rPr lang="zh-CN" altLang="en-US" smtClean="0"/>
-              <a:t>2025/11/17</a:t>
+              <a:t>2026/3/13</a:t>
             </a:fld>
             <a:endParaRPr lang="zh-CN" altLang="en-US"/>
           </a:p>
@@ -1414,7 +1415,7 @@
           <a:p>
             <a:fld id="{115BA0BE-EEFE-44F5-956C-0B3C1679C7A2}" type="datetimeFigureOut">
               <a:rPr lang="zh-CN" altLang="en-US" smtClean="0"/>
-              <a:t>2025/11/17</a:t>
+              <a:t>2026/3/13</a:t>
             </a:fld>
             <a:endParaRPr lang="zh-CN" altLang="en-US"/>
           </a:p>
@@ -1826,7 +1827,7 @@
           <a:p>
             <a:fld id="{115BA0BE-EEFE-44F5-956C-0B3C1679C7A2}" type="datetimeFigureOut">
               <a:rPr lang="zh-CN" altLang="en-US" smtClean="0"/>
-              <a:t>2025/11/17</a:t>
+              <a:t>2026/3/13</a:t>
             </a:fld>
             <a:endParaRPr lang="zh-CN" altLang="en-US"/>
           </a:p>
@@ -1967,7 +1968,7 @@
           <a:p>
             <a:fld id="{115BA0BE-EEFE-44F5-956C-0B3C1679C7A2}" type="datetimeFigureOut">
               <a:rPr lang="zh-CN" altLang="en-US" smtClean="0"/>
-              <a:t>2025/11/17</a:t>
+              <a:t>2026/3/13</a:t>
             </a:fld>
             <a:endParaRPr lang="zh-CN" altLang="en-US"/>
           </a:p>
@@ -2080,7 +2081,7 @@
           <a:p>
             <a:fld id="{115BA0BE-EEFE-44F5-956C-0B3C1679C7A2}" type="datetimeFigureOut">
               <a:rPr lang="zh-CN" altLang="en-US" smtClean="0"/>
-              <a:t>2025/11/17</a:t>
+              <a:t>2026/3/13</a:t>
             </a:fld>
             <a:endParaRPr lang="zh-CN" altLang="en-US"/>
           </a:p>
@@ -2391,7 +2392,7 @@
           <a:p>
             <a:fld id="{115BA0BE-EEFE-44F5-956C-0B3C1679C7A2}" type="datetimeFigureOut">
               <a:rPr lang="zh-CN" altLang="en-US" smtClean="0"/>
-              <a:t>2025/11/17</a:t>
+              <a:t>2026/3/13</a:t>
             </a:fld>
             <a:endParaRPr lang="zh-CN" altLang="en-US"/>
           </a:p>
@@ -2679,7 +2680,7 @@
           <a:p>
             <a:fld id="{115BA0BE-EEFE-44F5-956C-0B3C1679C7A2}" type="datetimeFigureOut">
               <a:rPr lang="zh-CN" altLang="en-US" smtClean="0"/>
-              <a:t>2025/11/17</a:t>
+              <a:t>2026/3/13</a:t>
             </a:fld>
             <a:endParaRPr lang="zh-CN" altLang="en-US"/>
           </a:p>
@@ -2920,7 +2921,7 @@
           <a:p>
             <a:fld id="{115BA0BE-EEFE-44F5-956C-0B3C1679C7A2}" type="datetimeFigureOut">
               <a:rPr lang="zh-CN" altLang="en-US" smtClean="0"/>
-              <a:t>2025/11/17</a:t>
+              <a:t>2026/3/13</a:t>
             </a:fld>
             <a:endParaRPr lang="zh-CN" altLang="en-US"/>
           </a:p>
@@ -3725,196 +3726,6 @@
           </a:p>
         </p:txBody>
       </p:sp>
-      <p:sp>
-        <p:nvSpPr>
-          <p:cNvPr id="16" name="文本框 15">
-            <a:extLst>
-              <a:ext uri="{FF2B5EF4-FFF2-40B4-BE49-F238E27FC236}">
-                <a16:creationId xmlns:a16="http://schemas.microsoft.com/office/drawing/2014/main" id="{4AE0AD8A-DE6C-E8C6-FB41-DC3048D76002}"/>
-              </a:ext>
-            </a:extLst>
-          </p:cNvPr>
-          <p:cNvSpPr txBox="1"/>
-          <p:nvPr/>
-        </p:nvSpPr>
-        <p:spPr>
-          <a:xfrm>
-            <a:off x="4852738" y="1373685"/>
-            <a:ext cx="609599" cy="461665"/>
-          </a:xfrm>
-          <a:prstGeom prst="rect">
-            <a:avLst/>
-          </a:prstGeom>
-          <a:noFill/>
-        </p:spPr>
-        <p:txBody>
-          <a:bodyPr wrap="square" rtlCol="0">
-            <a:spAutoFit/>
-          </a:bodyPr>
-          <a:lstStyle/>
-          <a:p>
-            <a:r>
-              <a:rPr lang="en-US" altLang="zh-CN" sz="2400" b="1" dirty="0">
-                <a:latin typeface="黑体" panose="02010609060101010101" pitchFamily="49" charset="-122"/>
-                <a:ea typeface="黑体" panose="02010609060101010101" pitchFamily="49" charset="-122"/>
-              </a:rPr>
-              <a:t>B1</a:t>
-            </a:r>
-          </a:p>
-        </p:txBody>
-      </p:sp>
-      <p:sp>
-        <p:nvSpPr>
-          <p:cNvPr id="17" name="文本框 16">
-            <a:extLst>
-              <a:ext uri="{FF2B5EF4-FFF2-40B4-BE49-F238E27FC236}">
-                <a16:creationId xmlns:a16="http://schemas.microsoft.com/office/drawing/2014/main" id="{017DDBF4-BDFF-9256-DFDB-F7FE61C65DEF}"/>
-              </a:ext>
-            </a:extLst>
-          </p:cNvPr>
-          <p:cNvSpPr txBox="1"/>
-          <p:nvPr/>
-        </p:nvSpPr>
-        <p:spPr>
-          <a:xfrm>
-            <a:off x="6490755" y="1834811"/>
-            <a:ext cx="609599" cy="461665"/>
-          </a:xfrm>
-          <a:prstGeom prst="rect">
-            <a:avLst/>
-          </a:prstGeom>
-          <a:noFill/>
-        </p:spPr>
-        <p:txBody>
-          <a:bodyPr wrap="square" rtlCol="0">
-            <a:spAutoFit/>
-          </a:bodyPr>
-          <a:lstStyle/>
-          <a:p>
-            <a:r>
-              <a:rPr lang="en-US" altLang="zh-CN" sz="2400" b="1" dirty="0">
-                <a:latin typeface="黑体" panose="02010609060101010101" pitchFamily="49" charset="-122"/>
-                <a:ea typeface="黑体" panose="02010609060101010101" pitchFamily="49" charset="-122"/>
-              </a:rPr>
-              <a:t>B2</a:t>
-            </a:r>
-          </a:p>
-        </p:txBody>
-      </p:sp>
-      <p:sp>
-        <p:nvSpPr>
-          <p:cNvPr id="18" name="文本框 17">
-            <a:extLst>
-              <a:ext uri="{FF2B5EF4-FFF2-40B4-BE49-F238E27FC236}">
-                <a16:creationId xmlns:a16="http://schemas.microsoft.com/office/drawing/2014/main" id="{660B3154-758A-3965-2822-50289BE78C2A}"/>
-              </a:ext>
-            </a:extLst>
-          </p:cNvPr>
-          <p:cNvSpPr txBox="1"/>
-          <p:nvPr/>
-        </p:nvSpPr>
-        <p:spPr>
-          <a:xfrm>
-            <a:off x="6723336" y="718553"/>
-            <a:ext cx="609599" cy="461665"/>
-          </a:xfrm>
-          <a:prstGeom prst="rect">
-            <a:avLst/>
-          </a:prstGeom>
-          <a:noFill/>
-        </p:spPr>
-        <p:txBody>
-          <a:bodyPr wrap="square" rtlCol="0">
-            <a:spAutoFit/>
-          </a:bodyPr>
-          <a:lstStyle/>
-          <a:p>
-            <a:r>
-              <a:rPr lang="en-US" altLang="zh-CN" sz="2400" b="1" dirty="0">
-                <a:latin typeface="黑体" panose="02010609060101010101" pitchFamily="49" charset="-122"/>
-                <a:ea typeface="黑体" panose="02010609060101010101" pitchFamily="49" charset="-122"/>
-              </a:rPr>
-              <a:t>B3</a:t>
-            </a:r>
-          </a:p>
-        </p:txBody>
-      </p:sp>
-      <p:sp>
-        <p:nvSpPr>
-          <p:cNvPr id="19" name="文本框 18">
-            <a:extLst>
-              <a:ext uri="{FF2B5EF4-FFF2-40B4-BE49-F238E27FC236}">
-                <a16:creationId xmlns:a16="http://schemas.microsoft.com/office/drawing/2014/main" id="{9239557F-645A-3B7A-D9F6-418B9767B591}"/>
-              </a:ext>
-            </a:extLst>
-          </p:cNvPr>
-          <p:cNvSpPr txBox="1"/>
-          <p:nvPr/>
-        </p:nvSpPr>
-        <p:spPr>
-          <a:xfrm>
-            <a:off x="2322030" y="1950719"/>
-            <a:ext cx="609599" cy="461665"/>
-          </a:xfrm>
-          <a:prstGeom prst="rect">
-            <a:avLst/>
-          </a:prstGeom>
-          <a:noFill/>
-        </p:spPr>
-        <p:txBody>
-          <a:bodyPr wrap="square" rtlCol="0">
-            <a:spAutoFit/>
-          </a:bodyPr>
-          <a:lstStyle/>
-          <a:p>
-            <a:r>
-              <a:rPr lang="en-US" altLang="zh-CN" sz="2400" b="1" dirty="0">
-                <a:latin typeface="黑体" panose="02010609060101010101" pitchFamily="49" charset="-122"/>
-                <a:ea typeface="黑体" panose="02010609060101010101" pitchFamily="49" charset="-122"/>
-              </a:rPr>
-              <a:t>A1</a:t>
-            </a:r>
-          </a:p>
-        </p:txBody>
-      </p:sp>
-      <p:sp>
-        <p:nvSpPr>
-          <p:cNvPr id="20" name="文本框 19">
-            <a:extLst>
-              <a:ext uri="{FF2B5EF4-FFF2-40B4-BE49-F238E27FC236}">
-                <a16:creationId xmlns:a16="http://schemas.microsoft.com/office/drawing/2014/main" id="{FAD4E744-849F-4525-B931-9C89ED95A87A}"/>
-              </a:ext>
-            </a:extLst>
-          </p:cNvPr>
-          <p:cNvSpPr txBox="1"/>
-          <p:nvPr/>
-        </p:nvSpPr>
-        <p:spPr>
-          <a:xfrm>
-            <a:off x="6096000" y="5761121"/>
-            <a:ext cx="609599" cy="461665"/>
-          </a:xfrm>
-          <a:prstGeom prst="rect">
-            <a:avLst/>
-          </a:prstGeom>
-          <a:noFill/>
-        </p:spPr>
-        <p:txBody>
-          <a:bodyPr wrap="square" rtlCol="0">
-            <a:spAutoFit/>
-          </a:bodyPr>
-          <a:lstStyle/>
-          <a:p>
-            <a:r>
-              <a:rPr lang="en-US" altLang="zh-CN" sz="2400" b="1" dirty="0">
-                <a:latin typeface="黑体" panose="02010609060101010101" pitchFamily="49" charset="-122"/>
-                <a:ea typeface="黑体" panose="02010609060101010101" pitchFamily="49" charset="-122"/>
-              </a:rPr>
-              <a:t>K1</a:t>
-            </a:r>
-          </a:p>
-        </p:txBody>
-      </p:sp>
       <p:cxnSp>
         <p:nvCxnSpPr>
           <p:cNvPr id="24" name="直接箭头连接符 23">
@@ -4046,12 +3857,795 @@
           </a:fontRef>
         </p:style>
       </p:cxnSp>
-      <p:sp>
-        <p:nvSpPr>
-          <p:cNvPr id="29" name="文本框 28">
-            <a:extLst>
-              <a:ext uri="{FF2B5EF4-FFF2-40B4-BE49-F238E27FC236}">
-                <a16:creationId xmlns:a16="http://schemas.microsoft.com/office/drawing/2014/main" id="{DE535EA7-52E8-1FD7-4E79-08B2AE348732}"/>
+      <p:graphicFrame>
+        <p:nvGraphicFramePr>
+          <p:cNvPr id="3" name="对象 2">
+            <a:extLst>
+              <a:ext uri="{FF2B5EF4-FFF2-40B4-BE49-F238E27FC236}">
+                <a16:creationId xmlns:a16="http://schemas.microsoft.com/office/drawing/2014/main" id="{0A9A211D-4630-910B-831C-586E2FC28F2B}"/>
+              </a:ext>
+            </a:extLst>
+          </p:cNvPr>
+          <p:cNvGraphicFramePr>
+            <a:graphicFrameLocks noChangeAspect="1"/>
+          </p:cNvGraphicFramePr>
+          <p:nvPr>
+            <p:extLst>
+              <p:ext uri="{D42A27DB-BD31-4B8C-83A1-F6EECF244321}">
+                <p14:modId xmlns:p14="http://schemas.microsoft.com/office/powerpoint/2010/main" val="1718580989"/>
+              </p:ext>
+            </p:extLst>
+          </p:nvPr>
+        </p:nvGraphicFramePr>
+        <p:xfrm>
+          <a:off x="4830201" y="1242862"/>
+          <a:ext cx="498921" cy="690813"/>
+        </p:xfrm>
+        <a:graphic>
+          <a:graphicData uri="http://schemas.openxmlformats.org/presentationml/2006/ole">
+            <mc:AlternateContent xmlns:mc="http://schemas.openxmlformats.org/markup-compatibility/2006">
+              <mc:Choice xmlns:v="urn:schemas-microsoft-com:vml" Requires="v">
+                <p:oleObj name="Equation" r:id="rId3" imgW="164880" imgH="228600" progId="Equation.DSMT4">
+                  <p:embed/>
+                </p:oleObj>
+              </mc:Choice>
+              <mc:Fallback>
+                <p:oleObj name="Equation" r:id="rId3" imgW="164880" imgH="228600" progId="Equation.DSMT4">
+                  <p:embed/>
+                  <p:pic>
+                    <p:nvPicPr>
+                      <p:cNvPr id="0" name=""/>
+                      <p:cNvPicPr/>
+                      <p:nvPr/>
+                    </p:nvPicPr>
+                    <p:blipFill>
+                      <a:blip r:embed="rId4"/>
+                      <a:stretch>
+                        <a:fillRect/>
+                      </a:stretch>
+                    </p:blipFill>
+                    <p:spPr>
+                      <a:xfrm>
+                        <a:off x="4830201" y="1242862"/>
+                        <a:ext cx="498921" cy="690813"/>
+                      </a:xfrm>
+                      <a:prstGeom prst="rect">
+                        <a:avLst/>
+                      </a:prstGeom>
+                    </p:spPr>
+                  </p:pic>
+                </p:oleObj>
+              </mc:Fallback>
+            </mc:AlternateContent>
+          </a:graphicData>
+        </a:graphic>
+      </p:graphicFrame>
+      <p:graphicFrame>
+        <p:nvGraphicFramePr>
+          <p:cNvPr id="4" name="对象 3">
+            <a:extLst>
+              <a:ext uri="{FF2B5EF4-FFF2-40B4-BE49-F238E27FC236}">
+                <a16:creationId xmlns:a16="http://schemas.microsoft.com/office/drawing/2014/main" id="{0D99C24C-5F36-498F-A2E8-6283B57EA2A4}"/>
+              </a:ext>
+            </a:extLst>
+          </p:cNvPr>
+          <p:cNvGraphicFramePr>
+            <a:graphicFrameLocks noChangeAspect="1"/>
+          </p:cNvGraphicFramePr>
+          <p:nvPr>
+            <p:extLst>
+              <p:ext uri="{D42A27DB-BD31-4B8C-83A1-F6EECF244321}">
+                <p14:modId xmlns:p14="http://schemas.microsoft.com/office/powerpoint/2010/main" val="844002752"/>
+              </p:ext>
+            </p:extLst>
+          </p:nvPr>
+        </p:nvGraphicFramePr>
+        <p:xfrm>
+          <a:off x="5844755" y="1311041"/>
+          <a:ext cx="441763" cy="478576"/>
+        </p:xfrm>
+        <a:graphic>
+          <a:graphicData uri="http://schemas.openxmlformats.org/presentationml/2006/ole">
+            <mc:AlternateContent xmlns:mc="http://schemas.openxmlformats.org/markup-compatibility/2006">
+              <mc:Choice xmlns:v="urn:schemas-microsoft-com:vml" Requires="v">
+                <p:oleObj name="Equation" r:id="rId5" imgW="152280" imgH="164880" progId="Equation.DSMT4">
+                  <p:embed/>
+                </p:oleObj>
+              </mc:Choice>
+              <mc:Fallback>
+                <p:oleObj name="Equation" r:id="rId5" imgW="152280" imgH="164880" progId="Equation.DSMT4">
+                  <p:embed/>
+                  <p:pic>
+                    <p:nvPicPr>
+                      <p:cNvPr id="0" name=""/>
+                      <p:cNvPicPr/>
+                      <p:nvPr/>
+                    </p:nvPicPr>
+                    <p:blipFill>
+                      <a:blip r:embed="rId6"/>
+                      <a:stretch>
+                        <a:fillRect/>
+                      </a:stretch>
+                    </p:blipFill>
+                    <p:spPr>
+                      <a:xfrm>
+                        <a:off x="5844755" y="1311041"/>
+                        <a:ext cx="441763" cy="478576"/>
+                      </a:xfrm>
+                      <a:prstGeom prst="rect">
+                        <a:avLst/>
+                      </a:prstGeom>
+                    </p:spPr>
+                  </p:pic>
+                </p:oleObj>
+              </mc:Fallback>
+            </mc:AlternateContent>
+          </a:graphicData>
+        </a:graphic>
+      </p:graphicFrame>
+      <p:graphicFrame>
+        <p:nvGraphicFramePr>
+          <p:cNvPr id="5" name="对象 4">
+            <a:extLst>
+              <a:ext uri="{FF2B5EF4-FFF2-40B4-BE49-F238E27FC236}">
+                <a16:creationId xmlns:a16="http://schemas.microsoft.com/office/drawing/2014/main" id="{3676E2F9-A418-26B9-D6F2-36FC490A4E48}"/>
+              </a:ext>
+            </a:extLst>
+          </p:cNvPr>
+          <p:cNvGraphicFramePr>
+            <a:graphicFrameLocks noChangeAspect="1"/>
+          </p:cNvGraphicFramePr>
+          <p:nvPr>
+            <p:extLst>
+              <p:ext uri="{D42A27DB-BD31-4B8C-83A1-F6EECF244321}">
+                <p14:modId xmlns:p14="http://schemas.microsoft.com/office/powerpoint/2010/main" val="3220212430"/>
+              </p:ext>
+            </p:extLst>
+          </p:nvPr>
+        </p:nvGraphicFramePr>
+        <p:xfrm>
+          <a:off x="6679621" y="5800499"/>
+          <a:ext cx="341007" cy="341007"/>
+        </p:xfrm>
+        <a:graphic>
+          <a:graphicData uri="http://schemas.openxmlformats.org/presentationml/2006/ole">
+            <mc:AlternateContent xmlns:mc="http://schemas.openxmlformats.org/markup-compatibility/2006">
+              <mc:Choice xmlns:v="urn:schemas-microsoft-com:vml" Requires="v">
+                <p:oleObj name="Equation" r:id="rId7" imgW="164880" imgH="164880" progId="Equation.DSMT4">
+                  <p:embed/>
+                </p:oleObj>
+              </mc:Choice>
+              <mc:Fallback>
+                <p:oleObj name="Equation" r:id="rId7" imgW="164880" imgH="164880" progId="Equation.DSMT4">
+                  <p:embed/>
+                  <p:pic>
+                    <p:nvPicPr>
+                      <p:cNvPr id="0" name=""/>
+                      <p:cNvPicPr/>
+                      <p:nvPr/>
+                    </p:nvPicPr>
+                    <p:blipFill>
+                      <a:blip r:embed="rId8"/>
+                      <a:stretch>
+                        <a:fillRect/>
+                      </a:stretch>
+                    </p:blipFill>
+                    <p:spPr>
+                      <a:xfrm>
+                        <a:off x="6679621" y="5800499"/>
+                        <a:ext cx="341007" cy="341007"/>
+                      </a:xfrm>
+                      <a:prstGeom prst="rect">
+                        <a:avLst/>
+                      </a:prstGeom>
+                    </p:spPr>
+                  </p:pic>
+                </p:oleObj>
+              </mc:Fallback>
+            </mc:AlternateContent>
+          </a:graphicData>
+        </a:graphic>
+      </p:graphicFrame>
+      <p:graphicFrame>
+        <p:nvGraphicFramePr>
+          <p:cNvPr id="7" name="对象 6">
+            <a:extLst>
+              <a:ext uri="{FF2B5EF4-FFF2-40B4-BE49-F238E27FC236}">
+                <a16:creationId xmlns:a16="http://schemas.microsoft.com/office/drawing/2014/main" id="{2C1C6EB6-FE35-FBC4-9F95-8072C80EFE8B}"/>
+              </a:ext>
+            </a:extLst>
+          </p:cNvPr>
+          <p:cNvGraphicFramePr>
+            <a:graphicFrameLocks noChangeAspect="1"/>
+          </p:cNvGraphicFramePr>
+          <p:nvPr>
+            <p:extLst>
+              <p:ext uri="{D42A27DB-BD31-4B8C-83A1-F6EECF244321}">
+                <p14:modId xmlns:p14="http://schemas.microsoft.com/office/powerpoint/2010/main" val="2339212522"/>
+              </p:ext>
+            </p:extLst>
+          </p:nvPr>
+        </p:nvGraphicFramePr>
+        <p:xfrm>
+          <a:off x="5997959" y="5714225"/>
+          <a:ext cx="434076" cy="520892"/>
+        </p:xfrm>
+        <a:graphic>
+          <a:graphicData uri="http://schemas.openxmlformats.org/presentationml/2006/ole">
+            <mc:AlternateContent xmlns:mc="http://schemas.openxmlformats.org/markup-compatibility/2006">
+              <mc:Choice xmlns:v="urn:schemas-microsoft-com:vml" Requires="v">
+                <p:oleObj name="Equation" r:id="rId9" imgW="190440" imgH="228600" progId="Equation.DSMT4">
+                  <p:embed/>
+                </p:oleObj>
+              </mc:Choice>
+              <mc:Fallback>
+                <p:oleObj name="Equation" r:id="rId9" imgW="190440" imgH="228600" progId="Equation.DSMT4">
+                  <p:embed/>
+                  <p:pic>
+                    <p:nvPicPr>
+                      <p:cNvPr id="0" name=""/>
+                      <p:cNvPicPr/>
+                      <p:nvPr/>
+                    </p:nvPicPr>
+                    <p:blipFill>
+                      <a:blip r:embed="rId10"/>
+                      <a:stretch>
+                        <a:fillRect/>
+                      </a:stretch>
+                    </p:blipFill>
+                    <p:spPr>
+                      <a:xfrm>
+                        <a:off x="5997959" y="5714225"/>
+                        <a:ext cx="434076" cy="520892"/>
+                      </a:xfrm>
+                      <a:prstGeom prst="rect">
+                        <a:avLst/>
+                      </a:prstGeom>
+                    </p:spPr>
+                  </p:pic>
+                </p:oleObj>
+              </mc:Fallback>
+            </mc:AlternateContent>
+          </a:graphicData>
+        </a:graphic>
+      </p:graphicFrame>
+      <p:graphicFrame>
+        <p:nvGraphicFramePr>
+          <p:cNvPr id="9" name="对象 8">
+            <a:extLst>
+              <a:ext uri="{FF2B5EF4-FFF2-40B4-BE49-F238E27FC236}">
+                <a16:creationId xmlns:a16="http://schemas.microsoft.com/office/drawing/2014/main" id="{659872F5-9E59-2509-CE96-76AB46DE8397}"/>
+              </a:ext>
+            </a:extLst>
+          </p:cNvPr>
+          <p:cNvGraphicFramePr>
+            <a:graphicFrameLocks noChangeAspect="1"/>
+          </p:cNvGraphicFramePr>
+          <p:nvPr>
+            <p:extLst>
+              <p:ext uri="{D42A27DB-BD31-4B8C-83A1-F6EECF244321}">
+                <p14:modId xmlns:p14="http://schemas.microsoft.com/office/powerpoint/2010/main" val="443654248"/>
+              </p:ext>
+            </p:extLst>
+          </p:nvPr>
+        </p:nvGraphicFramePr>
+        <p:xfrm>
+          <a:off x="4055104" y="3831235"/>
+          <a:ext cx="325842" cy="651684"/>
+        </p:xfrm>
+        <a:graphic>
+          <a:graphicData uri="http://schemas.openxmlformats.org/presentationml/2006/ole">
+            <mc:AlternateContent xmlns:mc="http://schemas.openxmlformats.org/markup-compatibility/2006">
+              <mc:Choice xmlns:v="urn:schemas-microsoft-com:vml" Requires="v">
+                <p:oleObj name="Equation" r:id="rId11" imgW="114120" imgH="228600" progId="Equation.DSMT4">
+                  <p:embed/>
+                </p:oleObj>
+              </mc:Choice>
+              <mc:Fallback>
+                <p:oleObj name="Equation" r:id="rId11" imgW="114120" imgH="228600" progId="Equation.DSMT4">
+                  <p:embed/>
+                  <p:pic>
+                    <p:nvPicPr>
+                      <p:cNvPr id="0" name=""/>
+                      <p:cNvPicPr/>
+                      <p:nvPr/>
+                    </p:nvPicPr>
+                    <p:blipFill>
+                      <a:blip r:embed="rId12"/>
+                      <a:stretch>
+                        <a:fillRect/>
+                      </a:stretch>
+                    </p:blipFill>
+                    <p:spPr>
+                      <a:xfrm>
+                        <a:off x="4055104" y="3831235"/>
+                        <a:ext cx="325842" cy="651684"/>
+                      </a:xfrm>
+                      <a:prstGeom prst="rect">
+                        <a:avLst/>
+                      </a:prstGeom>
+                    </p:spPr>
+                  </p:pic>
+                </p:oleObj>
+              </mc:Fallback>
+            </mc:AlternateContent>
+          </a:graphicData>
+        </a:graphic>
+      </p:graphicFrame>
+      <p:graphicFrame>
+        <p:nvGraphicFramePr>
+          <p:cNvPr id="22" name="对象 21">
+            <a:extLst>
+              <a:ext uri="{FF2B5EF4-FFF2-40B4-BE49-F238E27FC236}">
+                <a16:creationId xmlns:a16="http://schemas.microsoft.com/office/drawing/2014/main" id="{37B47B72-D1C7-C250-9634-CC14A068CE24}"/>
+              </a:ext>
+            </a:extLst>
+          </p:cNvPr>
+          <p:cNvGraphicFramePr>
+            <a:graphicFrameLocks noChangeAspect="1"/>
+          </p:cNvGraphicFramePr>
+          <p:nvPr>
+            <p:extLst>
+              <p:ext uri="{D42A27DB-BD31-4B8C-83A1-F6EECF244321}">
+                <p14:modId xmlns:p14="http://schemas.microsoft.com/office/powerpoint/2010/main" val="972080306"/>
+              </p:ext>
+            </p:extLst>
+          </p:nvPr>
+        </p:nvGraphicFramePr>
+        <p:xfrm>
+          <a:off x="3821163" y="1311041"/>
+          <a:ext cx="396861" cy="595292"/>
+        </p:xfrm>
+        <a:graphic>
+          <a:graphicData uri="http://schemas.openxmlformats.org/presentationml/2006/ole">
+            <mc:AlternateContent xmlns:mc="http://schemas.openxmlformats.org/markup-compatibility/2006">
+              <mc:Choice xmlns:v="urn:schemas-microsoft-com:vml" Requires="v">
+                <p:oleObj name="Equation" r:id="rId13" imgW="152280" imgH="228600" progId="Equation.DSMT4">
+                  <p:embed/>
+                </p:oleObj>
+              </mc:Choice>
+              <mc:Fallback>
+                <p:oleObj name="Equation" r:id="rId13" imgW="152280" imgH="228600" progId="Equation.DSMT4">
+                  <p:embed/>
+                  <p:pic>
+                    <p:nvPicPr>
+                      <p:cNvPr id="0" name=""/>
+                      <p:cNvPicPr/>
+                      <p:nvPr/>
+                    </p:nvPicPr>
+                    <p:blipFill>
+                      <a:blip r:embed="rId14"/>
+                      <a:stretch>
+                        <a:fillRect/>
+                      </a:stretch>
+                    </p:blipFill>
+                    <p:spPr>
+                      <a:xfrm>
+                        <a:off x="3821163" y="1311041"/>
+                        <a:ext cx="396861" cy="595292"/>
+                      </a:xfrm>
+                      <a:prstGeom prst="rect">
+                        <a:avLst/>
+                      </a:prstGeom>
+                    </p:spPr>
+                  </p:pic>
+                </p:oleObj>
+              </mc:Fallback>
+            </mc:AlternateContent>
+          </a:graphicData>
+        </a:graphic>
+      </p:graphicFrame>
+      <p:graphicFrame>
+        <p:nvGraphicFramePr>
+          <p:cNvPr id="23" name="对象 22">
+            <a:extLst>
+              <a:ext uri="{FF2B5EF4-FFF2-40B4-BE49-F238E27FC236}">
+                <a16:creationId xmlns:a16="http://schemas.microsoft.com/office/drawing/2014/main" id="{2C298EC6-AFAB-AB9B-C906-9EABB2C0A0E3}"/>
+              </a:ext>
+            </a:extLst>
+          </p:cNvPr>
+          <p:cNvGraphicFramePr>
+            <a:graphicFrameLocks noChangeAspect="1"/>
+          </p:cNvGraphicFramePr>
+          <p:nvPr>
+            <p:extLst>
+              <p:ext uri="{D42A27DB-BD31-4B8C-83A1-F6EECF244321}">
+                <p14:modId xmlns:p14="http://schemas.microsoft.com/office/powerpoint/2010/main" val="2594433369"/>
+              </p:ext>
+            </p:extLst>
+          </p:nvPr>
+        </p:nvGraphicFramePr>
+        <p:xfrm>
+          <a:off x="2310554" y="1719962"/>
+          <a:ext cx="441380" cy="611142"/>
+        </p:xfrm>
+        <a:graphic>
+          <a:graphicData uri="http://schemas.openxmlformats.org/presentationml/2006/ole">
+            <mc:AlternateContent xmlns:mc="http://schemas.openxmlformats.org/markup-compatibility/2006">
+              <mc:Choice xmlns:v="urn:schemas-microsoft-com:vml" Requires="v">
+                <p:oleObj name="Equation" r:id="rId15" imgW="164880" imgH="228600" progId="Equation.DSMT4">
+                  <p:embed/>
+                </p:oleObj>
+              </mc:Choice>
+              <mc:Fallback>
+                <p:oleObj name="Equation" r:id="rId15" imgW="164880" imgH="228600" progId="Equation.DSMT4">
+                  <p:embed/>
+                  <p:pic>
+                    <p:nvPicPr>
+                      <p:cNvPr id="0" name=""/>
+                      <p:cNvPicPr/>
+                      <p:nvPr/>
+                    </p:nvPicPr>
+                    <p:blipFill>
+                      <a:blip r:embed="rId16"/>
+                      <a:stretch>
+                        <a:fillRect/>
+                      </a:stretch>
+                    </p:blipFill>
+                    <p:spPr>
+                      <a:xfrm>
+                        <a:off x="2310554" y="1719962"/>
+                        <a:ext cx="441380" cy="611142"/>
+                      </a:xfrm>
+                      <a:prstGeom prst="rect">
+                        <a:avLst/>
+                      </a:prstGeom>
+                    </p:spPr>
+                  </p:pic>
+                </p:oleObj>
+              </mc:Fallback>
+            </mc:AlternateContent>
+          </a:graphicData>
+        </a:graphic>
+      </p:graphicFrame>
+    </p:spTree>
+    <p:extLst>
+      <p:ext uri="{BB962C8B-B14F-4D97-AF65-F5344CB8AC3E}">
+        <p14:creationId xmlns:p14="http://schemas.microsoft.com/office/powerpoint/2010/main" val="2552100656"/>
+      </p:ext>
+    </p:extLst>
+  </p:cSld>
+  <p:clrMapOvr>
+    <a:masterClrMapping/>
+  </p:clrMapOvr>
+</p:sld>
+</file>
+
+<file path=ppt/slides/slide2.xml><?xml version="1.0" encoding="utf-8"?>
+<p:sld xmlns:a="http://schemas.openxmlformats.org/drawingml/2006/main" xmlns:r="http://schemas.openxmlformats.org/officeDocument/2006/relationships" xmlns:p="http://schemas.openxmlformats.org/presentationml/2006/main">
+  <p:cSld>
+    <p:spTree>
+      <p:nvGrpSpPr>
+        <p:cNvPr id="1" name="">
+          <a:extLst>
+            <a:ext uri="{FF2B5EF4-FFF2-40B4-BE49-F238E27FC236}">
+              <a16:creationId xmlns:a16="http://schemas.microsoft.com/office/drawing/2014/main" id="{4B4F1019-E866-8887-D5FD-485E5D7DEA26}"/>
+            </a:ext>
+          </a:extLst>
+        </p:cNvPr>
+        <p:cNvGrpSpPr/>
+        <p:nvPr/>
+      </p:nvGrpSpPr>
+      <p:grpSpPr>
+        <a:xfrm>
+          <a:off x="0" y="0"/>
+          <a:ext cx="0" cy="0"/>
+          <a:chOff x="0" y="0"/>
+          <a:chExt cx="0" cy="0"/>
+        </a:xfrm>
+      </p:grpSpPr>
+      <p:pic>
+        <p:nvPicPr>
+          <p:cNvPr id="21" name="图片 20">
+            <a:extLst>
+              <a:ext uri="{FF2B5EF4-FFF2-40B4-BE49-F238E27FC236}">
+                <a16:creationId xmlns:a16="http://schemas.microsoft.com/office/drawing/2014/main" id="{34F250EF-7613-DCCC-4574-54F108E869AE}"/>
+              </a:ext>
+            </a:extLst>
+          </p:cNvPr>
+          <p:cNvPicPr>
+            <a:picLocks noChangeAspect="1"/>
+          </p:cNvPicPr>
+          <p:nvPr/>
+        </p:nvPicPr>
+        <p:blipFill>
+          <a:blip r:embed="rId2">
+            <a:extLst>
+              <a:ext uri="{28A0092B-C50C-407E-A947-70E740481C1C}">
+                <a14:useLocalDpi xmlns:a14="http://schemas.microsoft.com/office/drawing/2010/main" val="0"/>
+              </a:ext>
+            </a:extLst>
+          </a:blip>
+          <a:srcRect/>
+          <a:stretch/>
+        </p:blipFill>
+        <p:spPr>
+          <a:xfrm>
+            <a:off x="400252" y="-208208"/>
+            <a:ext cx="11368237" cy="6430994"/>
+          </a:xfrm>
+          <a:prstGeom prst="rect">
+            <a:avLst/>
+          </a:prstGeom>
+        </p:spPr>
+      </p:pic>
+      <p:cxnSp>
+        <p:nvCxnSpPr>
+          <p:cNvPr id="6" name="直接箭头连接符 5">
+            <a:extLst>
+              <a:ext uri="{FF2B5EF4-FFF2-40B4-BE49-F238E27FC236}">
+                <a16:creationId xmlns:a16="http://schemas.microsoft.com/office/drawing/2014/main" id="{FB72AD7D-2954-6D9B-7BF2-9D2D4ACF9C0C}"/>
+              </a:ext>
+            </a:extLst>
+          </p:cNvPr>
+          <p:cNvCxnSpPr>
+            <a:cxnSpLocks/>
+          </p:cNvCxnSpPr>
+          <p:nvPr/>
+        </p:nvCxnSpPr>
+        <p:spPr>
+          <a:xfrm flipH="1">
+            <a:off x="5250010" y="2074138"/>
+            <a:ext cx="629488" cy="49822"/>
+          </a:xfrm>
+          <a:prstGeom prst="straightConnector1">
+            <a:avLst/>
+          </a:prstGeom>
+          <a:ln w="50800">
+            <a:solidFill>
+              <a:srgbClr val="FF0000"/>
+            </a:solidFill>
+            <a:tailEnd type="triangle"/>
+          </a:ln>
+        </p:spPr>
+        <p:style>
+          <a:lnRef idx="1">
+            <a:schemeClr val="accent1"/>
+          </a:lnRef>
+          <a:fillRef idx="0">
+            <a:schemeClr val="accent1"/>
+          </a:fillRef>
+          <a:effectRef idx="0">
+            <a:schemeClr val="accent1"/>
+          </a:effectRef>
+          <a:fontRef idx="minor">
+            <a:schemeClr val="tx1"/>
+          </a:fontRef>
+        </p:style>
+      </p:cxnSp>
+      <p:cxnSp>
+        <p:nvCxnSpPr>
+          <p:cNvPr id="8" name="直接箭头连接符 7">
+            <a:extLst>
+              <a:ext uri="{FF2B5EF4-FFF2-40B4-BE49-F238E27FC236}">
+                <a16:creationId xmlns:a16="http://schemas.microsoft.com/office/drawing/2014/main" id="{BA170842-DE5B-E4F3-9273-4109A36DAA3B}"/>
+              </a:ext>
+            </a:extLst>
+          </p:cNvPr>
+          <p:cNvCxnSpPr>
+            <a:cxnSpLocks/>
+            <a:stCxn id="11" idx="2"/>
+          </p:cNvCxnSpPr>
+          <p:nvPr/>
+        </p:nvCxnSpPr>
+        <p:spPr>
+          <a:xfrm flipH="1">
+            <a:off x="3848696" y="2113466"/>
+            <a:ext cx="1336027" cy="135213"/>
+          </a:xfrm>
+          <a:prstGeom prst="straightConnector1">
+            <a:avLst/>
+          </a:prstGeom>
+          <a:ln w="50800">
+            <a:solidFill>
+              <a:srgbClr val="FF0000"/>
+            </a:solidFill>
+            <a:tailEnd type="triangle"/>
+          </a:ln>
+        </p:spPr>
+        <p:style>
+          <a:lnRef idx="1">
+            <a:schemeClr val="accent1"/>
+          </a:lnRef>
+          <a:fillRef idx="0">
+            <a:schemeClr val="accent1"/>
+          </a:fillRef>
+          <a:effectRef idx="0">
+            <a:schemeClr val="accent1"/>
+          </a:effectRef>
+          <a:fontRef idx="minor">
+            <a:schemeClr val="tx1"/>
+          </a:fontRef>
+        </p:style>
+      </p:cxnSp>
+      <p:cxnSp>
+        <p:nvCxnSpPr>
+          <p:cNvPr id="10" name="直接箭头连接符 9">
+            <a:extLst>
+              <a:ext uri="{FF2B5EF4-FFF2-40B4-BE49-F238E27FC236}">
+                <a16:creationId xmlns:a16="http://schemas.microsoft.com/office/drawing/2014/main" id="{DAACF6B9-778A-8209-5359-8080F50901EE}"/>
+              </a:ext>
+            </a:extLst>
+          </p:cNvPr>
+          <p:cNvCxnSpPr>
+            <a:cxnSpLocks/>
+          </p:cNvCxnSpPr>
+          <p:nvPr/>
+        </p:nvCxnSpPr>
+        <p:spPr>
+          <a:xfrm>
+            <a:off x="3848696" y="2262925"/>
+            <a:ext cx="2184929" cy="1966187"/>
+          </a:xfrm>
+          <a:prstGeom prst="straightConnector1">
+            <a:avLst/>
+          </a:prstGeom>
+          <a:ln w="50800">
+            <a:solidFill>
+              <a:srgbClr val="FF0000"/>
+            </a:solidFill>
+            <a:tailEnd type="triangle"/>
+          </a:ln>
+        </p:spPr>
+        <p:style>
+          <a:lnRef idx="1">
+            <a:schemeClr val="accent1"/>
+          </a:lnRef>
+          <a:fillRef idx="0">
+            <a:schemeClr val="accent1"/>
+          </a:fillRef>
+          <a:effectRef idx="0">
+            <a:schemeClr val="accent1"/>
+          </a:effectRef>
+          <a:fontRef idx="minor">
+            <a:schemeClr val="tx1"/>
+          </a:fontRef>
+        </p:style>
+      </p:cxnSp>
+      <p:sp>
+        <p:nvSpPr>
+          <p:cNvPr id="11" name="流程图: 接点 10">
+            <a:extLst>
+              <a:ext uri="{FF2B5EF4-FFF2-40B4-BE49-F238E27FC236}">
+                <a16:creationId xmlns:a16="http://schemas.microsoft.com/office/drawing/2014/main" id="{6CAEBD35-A900-C00B-AB2E-34C15D19C73D}"/>
+              </a:ext>
+            </a:extLst>
+          </p:cNvPr>
+          <p:cNvSpPr/>
+          <p:nvPr/>
+        </p:nvSpPr>
+        <p:spPr>
+          <a:xfrm>
+            <a:off x="5184723" y="2079376"/>
+            <a:ext cx="60158" cy="68179"/>
+          </a:xfrm>
+          <a:prstGeom prst="flowChartConnector">
+            <a:avLst/>
+          </a:prstGeom>
+        </p:spPr>
+        <p:style>
+          <a:lnRef idx="2">
+            <a:schemeClr val="dk1">
+              <a:shade val="15000"/>
+            </a:schemeClr>
+          </a:lnRef>
+          <a:fillRef idx="1">
+            <a:schemeClr val="dk1"/>
+          </a:fillRef>
+          <a:effectRef idx="0">
+            <a:schemeClr val="dk1"/>
+          </a:effectRef>
+          <a:fontRef idx="minor">
+            <a:schemeClr val="lt1"/>
+          </a:fontRef>
+        </p:style>
+        <p:txBody>
+          <a:bodyPr rtlCol="0" anchor="ctr"/>
+          <a:lstStyle/>
+          <a:p>
+            <a:pPr algn="ctr"/>
+            <a:endParaRPr lang="zh-CN" altLang="en-US"/>
+          </a:p>
+        </p:txBody>
+      </p:sp>
+      <p:sp>
+        <p:nvSpPr>
+          <p:cNvPr id="13" name="流程图: 接点 12">
+            <a:extLst>
+              <a:ext uri="{FF2B5EF4-FFF2-40B4-BE49-F238E27FC236}">
+                <a16:creationId xmlns:a16="http://schemas.microsoft.com/office/drawing/2014/main" id="{B4C6A93A-0190-1CED-B15D-C20E84E85884}"/>
+              </a:ext>
+            </a:extLst>
+          </p:cNvPr>
+          <p:cNvSpPr/>
+          <p:nvPr/>
+        </p:nvSpPr>
+        <p:spPr>
+          <a:xfrm>
+            <a:off x="6943915" y="1242862"/>
+            <a:ext cx="60158" cy="68179"/>
+          </a:xfrm>
+          <a:prstGeom prst="flowChartConnector">
+            <a:avLst/>
+          </a:prstGeom>
+        </p:spPr>
+        <p:style>
+          <a:lnRef idx="2">
+            <a:schemeClr val="dk1">
+              <a:shade val="15000"/>
+            </a:schemeClr>
+          </a:lnRef>
+          <a:fillRef idx="1">
+            <a:schemeClr val="dk1"/>
+          </a:fillRef>
+          <a:effectRef idx="0">
+            <a:schemeClr val="dk1"/>
+          </a:effectRef>
+          <a:fontRef idx="minor">
+            <a:schemeClr val="lt1"/>
+          </a:fontRef>
+        </p:style>
+        <p:txBody>
+          <a:bodyPr rtlCol="0" anchor="ctr"/>
+          <a:lstStyle/>
+          <a:p>
+            <a:pPr algn="ctr"/>
+            <a:endParaRPr lang="zh-CN" altLang="en-US"/>
+          </a:p>
+        </p:txBody>
+      </p:sp>
+      <p:sp>
+        <p:nvSpPr>
+          <p:cNvPr id="14" name="流程图: 接点 13">
+            <a:extLst>
+              <a:ext uri="{FF2B5EF4-FFF2-40B4-BE49-F238E27FC236}">
+                <a16:creationId xmlns:a16="http://schemas.microsoft.com/office/drawing/2014/main" id="{90F2151F-05D3-B1FF-E17C-C6B1C486CDBF}"/>
+              </a:ext>
+            </a:extLst>
+          </p:cNvPr>
+          <p:cNvSpPr/>
+          <p:nvPr/>
+        </p:nvSpPr>
+        <p:spPr>
+          <a:xfrm>
+            <a:off x="3817805" y="2214589"/>
+            <a:ext cx="60158" cy="68179"/>
+          </a:xfrm>
+          <a:prstGeom prst="flowChartConnector">
+            <a:avLst/>
+          </a:prstGeom>
+        </p:spPr>
+        <p:style>
+          <a:lnRef idx="2">
+            <a:schemeClr val="dk1">
+              <a:shade val="15000"/>
+            </a:schemeClr>
+          </a:lnRef>
+          <a:fillRef idx="1">
+            <a:schemeClr val="dk1"/>
+          </a:fillRef>
+          <a:effectRef idx="0">
+            <a:schemeClr val="dk1"/>
+          </a:effectRef>
+          <a:fontRef idx="minor">
+            <a:schemeClr val="lt1"/>
+          </a:fontRef>
+        </p:style>
+        <p:txBody>
+          <a:bodyPr rtlCol="0" anchor="ctr"/>
+          <a:lstStyle/>
+          <a:p>
+            <a:pPr algn="ctr"/>
+            <a:endParaRPr lang="zh-CN" altLang="en-US"/>
+          </a:p>
+        </p:txBody>
+      </p:sp>
+      <p:sp>
+        <p:nvSpPr>
+          <p:cNvPr id="16" name="文本框 15">
+            <a:extLst>
+              <a:ext uri="{FF2B5EF4-FFF2-40B4-BE49-F238E27FC236}">
+                <a16:creationId xmlns:a16="http://schemas.microsoft.com/office/drawing/2014/main" id="{FC5DF083-0E9E-93D4-A1B8-93C32AB95CCD}"/>
               </a:ext>
             </a:extLst>
           </p:cNvPr>
@@ -4060,7 +4654,331 @@
         </p:nvSpPr>
         <p:spPr>
           <a:xfrm>
-            <a:off x="5890286" y="1350090"/>
+            <a:off x="4852738" y="1373685"/>
+            <a:ext cx="609599" cy="461665"/>
+          </a:xfrm>
+          <a:prstGeom prst="rect">
+            <a:avLst/>
+          </a:prstGeom>
+          <a:noFill/>
+        </p:spPr>
+        <p:txBody>
+          <a:bodyPr wrap="square" rtlCol="0">
+            <a:spAutoFit/>
+          </a:bodyPr>
+          <a:lstStyle/>
+          <a:p>
+            <a:r>
+              <a:rPr lang="en-US" altLang="zh-CN" sz="2400" b="1" dirty="0">
+                <a:latin typeface="黑体" panose="02010609060101010101" pitchFamily="49" charset="-122"/>
+                <a:ea typeface="黑体" panose="02010609060101010101" pitchFamily="49" charset="-122"/>
+              </a:rPr>
+              <a:t>B1</a:t>
+            </a:r>
+          </a:p>
+        </p:txBody>
+      </p:sp>
+      <p:sp>
+        <p:nvSpPr>
+          <p:cNvPr id="17" name="文本框 16">
+            <a:extLst>
+              <a:ext uri="{FF2B5EF4-FFF2-40B4-BE49-F238E27FC236}">
+                <a16:creationId xmlns:a16="http://schemas.microsoft.com/office/drawing/2014/main" id="{73215544-D3BA-4F15-09DD-5265762E99FD}"/>
+              </a:ext>
+            </a:extLst>
+          </p:cNvPr>
+          <p:cNvSpPr txBox="1"/>
+          <p:nvPr/>
+        </p:nvSpPr>
+        <p:spPr>
+          <a:xfrm>
+            <a:off x="6490755" y="1834811"/>
+            <a:ext cx="609599" cy="461665"/>
+          </a:xfrm>
+          <a:prstGeom prst="rect">
+            <a:avLst/>
+          </a:prstGeom>
+          <a:noFill/>
+        </p:spPr>
+        <p:txBody>
+          <a:bodyPr wrap="square" rtlCol="0">
+            <a:spAutoFit/>
+          </a:bodyPr>
+          <a:lstStyle/>
+          <a:p>
+            <a:r>
+              <a:rPr lang="en-US" altLang="zh-CN" sz="2400" b="1" dirty="0">
+                <a:latin typeface="黑体" panose="02010609060101010101" pitchFamily="49" charset="-122"/>
+                <a:ea typeface="黑体" panose="02010609060101010101" pitchFamily="49" charset="-122"/>
+              </a:rPr>
+              <a:t>B2</a:t>
+            </a:r>
+          </a:p>
+        </p:txBody>
+      </p:sp>
+      <p:sp>
+        <p:nvSpPr>
+          <p:cNvPr id="18" name="文本框 17">
+            <a:extLst>
+              <a:ext uri="{FF2B5EF4-FFF2-40B4-BE49-F238E27FC236}">
+                <a16:creationId xmlns:a16="http://schemas.microsoft.com/office/drawing/2014/main" id="{E6ED6A5A-2EC1-8FD7-0EB5-55C22A4D5F48}"/>
+              </a:ext>
+            </a:extLst>
+          </p:cNvPr>
+          <p:cNvSpPr txBox="1"/>
+          <p:nvPr/>
+        </p:nvSpPr>
+        <p:spPr>
+          <a:xfrm>
+            <a:off x="5719588" y="1091494"/>
+            <a:ext cx="609599" cy="461665"/>
+          </a:xfrm>
+          <a:prstGeom prst="rect">
+            <a:avLst/>
+          </a:prstGeom>
+          <a:noFill/>
+        </p:spPr>
+        <p:txBody>
+          <a:bodyPr wrap="square" rtlCol="0">
+            <a:spAutoFit/>
+          </a:bodyPr>
+          <a:lstStyle/>
+          <a:p>
+            <a:r>
+              <a:rPr lang="en-US" altLang="zh-CN" sz="2400" b="1" dirty="0">
+                <a:latin typeface="黑体" panose="02010609060101010101" pitchFamily="49" charset="-122"/>
+                <a:ea typeface="黑体" panose="02010609060101010101" pitchFamily="49" charset="-122"/>
+              </a:rPr>
+              <a:t>B3</a:t>
+            </a:r>
+          </a:p>
+        </p:txBody>
+      </p:sp>
+      <p:sp>
+        <p:nvSpPr>
+          <p:cNvPr id="19" name="文本框 18">
+            <a:extLst>
+              <a:ext uri="{FF2B5EF4-FFF2-40B4-BE49-F238E27FC236}">
+                <a16:creationId xmlns:a16="http://schemas.microsoft.com/office/drawing/2014/main" id="{F1BFE347-A597-47B2-2A71-264FC69EAE68}"/>
+              </a:ext>
+            </a:extLst>
+          </p:cNvPr>
+          <p:cNvSpPr txBox="1"/>
+          <p:nvPr/>
+        </p:nvSpPr>
+        <p:spPr>
+          <a:xfrm>
+            <a:off x="3290388" y="1957363"/>
+            <a:ext cx="609599" cy="461665"/>
+          </a:xfrm>
+          <a:prstGeom prst="rect">
+            <a:avLst/>
+          </a:prstGeom>
+          <a:noFill/>
+        </p:spPr>
+        <p:txBody>
+          <a:bodyPr wrap="square" rtlCol="0">
+            <a:spAutoFit/>
+          </a:bodyPr>
+          <a:lstStyle/>
+          <a:p>
+            <a:r>
+              <a:rPr lang="en-US" altLang="zh-CN" sz="2400" b="1" dirty="0">
+                <a:latin typeface="黑体" panose="02010609060101010101" pitchFamily="49" charset="-122"/>
+                <a:ea typeface="黑体" panose="02010609060101010101" pitchFamily="49" charset="-122"/>
+              </a:rPr>
+              <a:t>A1</a:t>
+            </a:r>
+          </a:p>
+        </p:txBody>
+      </p:sp>
+      <p:sp>
+        <p:nvSpPr>
+          <p:cNvPr id="20" name="文本框 19">
+            <a:extLst>
+              <a:ext uri="{FF2B5EF4-FFF2-40B4-BE49-F238E27FC236}">
+                <a16:creationId xmlns:a16="http://schemas.microsoft.com/office/drawing/2014/main" id="{FD80D2B7-1B92-758E-E435-5F419DBB0FCE}"/>
+              </a:ext>
+            </a:extLst>
+          </p:cNvPr>
+          <p:cNvSpPr txBox="1"/>
+          <p:nvPr/>
+        </p:nvSpPr>
+        <p:spPr>
+          <a:xfrm>
+            <a:off x="5752231" y="4237749"/>
+            <a:ext cx="609599" cy="461665"/>
+          </a:xfrm>
+          <a:prstGeom prst="rect">
+            <a:avLst/>
+          </a:prstGeom>
+          <a:noFill/>
+        </p:spPr>
+        <p:txBody>
+          <a:bodyPr wrap="square" rtlCol="0">
+            <a:spAutoFit/>
+          </a:bodyPr>
+          <a:lstStyle/>
+          <a:p>
+            <a:r>
+              <a:rPr lang="en-US" altLang="zh-CN" sz="2400" b="1" dirty="0">
+                <a:latin typeface="黑体" panose="02010609060101010101" pitchFamily="49" charset="-122"/>
+                <a:ea typeface="黑体" panose="02010609060101010101" pitchFamily="49" charset="-122"/>
+              </a:rPr>
+              <a:t>K1</a:t>
+            </a:r>
+          </a:p>
+        </p:txBody>
+      </p:sp>
+      <p:cxnSp>
+        <p:nvCxnSpPr>
+          <p:cNvPr id="24" name="直接箭头连接符 23">
+            <a:extLst>
+              <a:ext uri="{FF2B5EF4-FFF2-40B4-BE49-F238E27FC236}">
+                <a16:creationId xmlns:a16="http://schemas.microsoft.com/office/drawing/2014/main" id="{7EB1DAE5-5BAE-493B-9ED9-DA6C876D9EC3}"/>
+              </a:ext>
+            </a:extLst>
+          </p:cNvPr>
+          <p:cNvCxnSpPr>
+            <a:cxnSpLocks/>
+          </p:cNvCxnSpPr>
+          <p:nvPr/>
+        </p:nvCxnSpPr>
+        <p:spPr>
+          <a:xfrm>
+            <a:off x="5923194" y="2065643"/>
+            <a:ext cx="405993" cy="2143009"/>
+          </a:xfrm>
+          <a:prstGeom prst="straightConnector1">
+            <a:avLst/>
+          </a:prstGeom>
+          <a:ln w="50800">
+            <a:solidFill>
+              <a:srgbClr val="FF0000"/>
+            </a:solidFill>
+            <a:tailEnd type="triangle"/>
+          </a:ln>
+        </p:spPr>
+        <p:style>
+          <a:lnRef idx="1">
+            <a:schemeClr val="accent1"/>
+          </a:lnRef>
+          <a:fillRef idx="0">
+            <a:schemeClr val="accent1"/>
+          </a:fillRef>
+          <a:effectRef idx="0">
+            <a:schemeClr val="accent1"/>
+          </a:effectRef>
+          <a:fontRef idx="minor">
+            <a:schemeClr val="tx1"/>
+          </a:fontRef>
+        </p:style>
+      </p:cxnSp>
+      <p:cxnSp>
+        <p:nvCxnSpPr>
+          <p:cNvPr id="26" name="直接箭头连接符 25">
+            <a:extLst>
+              <a:ext uri="{FF2B5EF4-FFF2-40B4-BE49-F238E27FC236}">
+                <a16:creationId xmlns:a16="http://schemas.microsoft.com/office/drawing/2014/main" id="{5337599A-D2DA-3A3C-58E6-157EB96F186A}"/>
+              </a:ext>
+            </a:extLst>
+          </p:cNvPr>
+          <p:cNvCxnSpPr>
+            <a:cxnSpLocks/>
+          </p:cNvCxnSpPr>
+          <p:nvPr/>
+        </p:nvCxnSpPr>
+        <p:spPr>
+          <a:xfrm flipH="1">
+            <a:off x="6033625" y="4208652"/>
+            <a:ext cx="340392" cy="58194"/>
+          </a:xfrm>
+          <a:prstGeom prst="straightConnector1">
+            <a:avLst/>
+          </a:prstGeom>
+          <a:ln w="50800">
+            <a:solidFill>
+              <a:srgbClr val="FF0000"/>
+            </a:solidFill>
+            <a:tailEnd type="triangle"/>
+          </a:ln>
+        </p:spPr>
+        <p:style>
+          <a:lnRef idx="1">
+            <a:schemeClr val="accent1"/>
+          </a:lnRef>
+          <a:fillRef idx="0">
+            <a:schemeClr val="accent1"/>
+          </a:fillRef>
+          <a:effectRef idx="0">
+            <a:schemeClr val="accent1"/>
+          </a:effectRef>
+          <a:fontRef idx="minor">
+            <a:schemeClr val="tx1"/>
+          </a:fontRef>
+        </p:style>
+      </p:cxnSp>
+      <p:cxnSp>
+        <p:nvCxnSpPr>
+          <p:cNvPr id="28" name="直接箭头连接符 27">
+            <a:extLst>
+              <a:ext uri="{FF2B5EF4-FFF2-40B4-BE49-F238E27FC236}">
+                <a16:creationId xmlns:a16="http://schemas.microsoft.com/office/drawing/2014/main" id="{C1762D16-626E-7C2A-CE26-21A245DBD5BA}"/>
+              </a:ext>
+            </a:extLst>
+          </p:cNvPr>
+          <p:cNvCxnSpPr>
+            <a:cxnSpLocks/>
+            <a:endCxn id="15" idx="6"/>
+          </p:cNvCxnSpPr>
+          <p:nvPr/>
+        </p:nvCxnSpPr>
+        <p:spPr>
+          <a:xfrm>
+            <a:off x="5879498" y="2113465"/>
+            <a:ext cx="193828" cy="2134515"/>
+          </a:xfrm>
+          <a:prstGeom prst="straightConnector1">
+            <a:avLst/>
+          </a:prstGeom>
+          <a:ln w="41275">
+            <a:solidFill>
+              <a:schemeClr val="accent2"/>
+            </a:solidFill>
+            <a:prstDash val="lgDash"/>
+            <a:tailEnd type="triangle"/>
+          </a:ln>
+        </p:spPr>
+        <p:style>
+          <a:lnRef idx="1">
+            <a:schemeClr val="accent1"/>
+          </a:lnRef>
+          <a:fillRef idx="0">
+            <a:schemeClr val="accent1"/>
+          </a:fillRef>
+          <a:effectRef idx="0">
+            <a:schemeClr val="accent1"/>
+          </a:effectRef>
+          <a:fontRef idx="minor">
+            <a:schemeClr val="tx1"/>
+          </a:fontRef>
+        </p:style>
+      </p:cxnSp>
+      <p:sp>
+        <p:nvSpPr>
+          <p:cNvPr id="29" name="文本框 28">
+            <a:extLst>
+              <a:ext uri="{FF2B5EF4-FFF2-40B4-BE49-F238E27FC236}">
+                <a16:creationId xmlns:a16="http://schemas.microsoft.com/office/drawing/2014/main" id="{A6C1388D-BB66-07F1-21F8-EA410C9499FC}"/>
+              </a:ext>
+            </a:extLst>
+          </p:cNvPr>
+          <p:cNvSpPr txBox="1"/>
+          <p:nvPr/>
+        </p:nvSpPr>
+        <p:spPr>
+          <a:xfrm>
+            <a:off x="5779572" y="1627889"/>
             <a:ext cx="609599" cy="461665"/>
           </a:xfrm>
           <a:prstGeom prst="rect">
@@ -4089,7 +5007,7 @@
           <p:cNvPr id="30" name="文本框 29">
             <a:extLst>
               <a:ext uri="{FF2B5EF4-FFF2-40B4-BE49-F238E27FC236}">
-                <a16:creationId xmlns:a16="http://schemas.microsoft.com/office/drawing/2014/main" id="{3E800860-E1A1-DF01-E4D7-9DEBE7F2239B}"/>
+                <a16:creationId xmlns:a16="http://schemas.microsoft.com/office/drawing/2014/main" id="{EC084E5B-C529-16AE-7C7D-E2410ABEF9C0}"/>
               </a:ext>
             </a:extLst>
           </p:cNvPr>
@@ -4098,7 +5016,7 @@
         </p:nvSpPr>
         <p:spPr>
           <a:xfrm>
-            <a:off x="6679621" y="5602378"/>
+            <a:off x="6394474" y="4143470"/>
             <a:ext cx="609599" cy="461665"/>
           </a:xfrm>
           <a:prstGeom prst="rect">
@@ -4127,7 +5045,7 @@
           <p:cNvPr id="31" name="文本框 30">
             <a:extLst>
               <a:ext uri="{FF2B5EF4-FFF2-40B4-BE49-F238E27FC236}">
-                <a16:creationId xmlns:a16="http://schemas.microsoft.com/office/drawing/2014/main" id="{26B9EC2A-BF0C-AAB6-F16F-419D17A7F77D}"/>
+                <a16:creationId xmlns:a16="http://schemas.microsoft.com/office/drawing/2014/main" id="{8539AD3B-F6E7-349C-9FC6-A5E3A50A7B8E}"/>
               </a:ext>
             </a:extLst>
           </p:cNvPr>
@@ -4136,7 +5054,7 @@
         </p:nvSpPr>
         <p:spPr>
           <a:xfrm>
-            <a:off x="3619992" y="1438897"/>
+            <a:off x="4171328" y="1668846"/>
             <a:ext cx="609599" cy="461665"/>
           </a:xfrm>
           <a:prstGeom prst="rect">
@@ -4185,7 +5103,7 @@
           <p:cNvPr id="32" name="文本框 31">
             <a:extLst>
               <a:ext uri="{FF2B5EF4-FFF2-40B4-BE49-F238E27FC236}">
-                <a16:creationId xmlns:a16="http://schemas.microsoft.com/office/drawing/2014/main" id="{7536686A-DE30-873D-03D0-4A74135222BE}"/>
+                <a16:creationId xmlns:a16="http://schemas.microsoft.com/office/drawing/2014/main" id="{1F960AA7-731A-309E-EB77-AC812E737784}"/>
               </a:ext>
             </a:extLst>
           </p:cNvPr>
@@ -4194,7 +5112,7 @@
         </p:nvSpPr>
         <p:spPr>
           <a:xfrm>
-            <a:off x="3893152" y="3746987"/>
+            <a:off x="4575124" y="3246018"/>
             <a:ext cx="609599" cy="461665"/>
           </a:xfrm>
           <a:prstGeom prst="rect">
@@ -4238,10 +5156,148 @@
           </a:p>
         </p:txBody>
       </p:sp>
+      <p:sp>
+        <p:nvSpPr>
+          <p:cNvPr id="15" name="流程图: 接点 14">
+            <a:extLst>
+              <a:ext uri="{FF2B5EF4-FFF2-40B4-BE49-F238E27FC236}">
+                <a16:creationId xmlns:a16="http://schemas.microsoft.com/office/drawing/2014/main" id="{CEB63C25-ADA1-56CB-F184-5E5E4624D0AC}"/>
+              </a:ext>
+            </a:extLst>
+          </p:cNvPr>
+          <p:cNvSpPr/>
+          <p:nvPr/>
+        </p:nvSpPr>
+        <p:spPr>
+          <a:xfrm>
+            <a:off x="6013168" y="4213890"/>
+            <a:ext cx="60158" cy="68179"/>
+          </a:xfrm>
+          <a:prstGeom prst="flowChartConnector">
+            <a:avLst/>
+          </a:prstGeom>
+        </p:spPr>
+        <p:style>
+          <a:lnRef idx="2">
+            <a:schemeClr val="dk1">
+              <a:shade val="15000"/>
+            </a:schemeClr>
+          </a:lnRef>
+          <a:fillRef idx="1">
+            <a:schemeClr val="dk1"/>
+          </a:fillRef>
+          <a:effectRef idx="0">
+            <a:schemeClr val="dk1"/>
+          </a:effectRef>
+          <a:fontRef idx="minor">
+            <a:schemeClr val="lt1"/>
+          </a:fontRef>
+        </p:style>
+        <p:txBody>
+          <a:bodyPr rtlCol="0" anchor="ctr"/>
+          <a:lstStyle/>
+          <a:p>
+            <a:pPr algn="ctr"/>
+            <a:endParaRPr lang="zh-CN" altLang="en-US"/>
+          </a:p>
+        </p:txBody>
+      </p:sp>
+      <p:sp>
+        <p:nvSpPr>
+          <p:cNvPr id="12" name="流程图: 接点 11">
+            <a:extLst>
+              <a:ext uri="{FF2B5EF4-FFF2-40B4-BE49-F238E27FC236}">
+                <a16:creationId xmlns:a16="http://schemas.microsoft.com/office/drawing/2014/main" id="{045A1E53-5F84-CCE8-CDA7-84DE8F55FEAA}"/>
+              </a:ext>
+            </a:extLst>
+          </p:cNvPr>
+          <p:cNvSpPr/>
+          <p:nvPr/>
+        </p:nvSpPr>
+        <p:spPr>
+          <a:xfrm>
+            <a:off x="5863036" y="2045041"/>
+            <a:ext cx="60158" cy="68179"/>
+          </a:xfrm>
+          <a:prstGeom prst="flowChartConnector">
+            <a:avLst/>
+          </a:prstGeom>
+        </p:spPr>
+        <p:style>
+          <a:lnRef idx="2">
+            <a:schemeClr val="dk1">
+              <a:shade val="15000"/>
+            </a:schemeClr>
+          </a:lnRef>
+          <a:fillRef idx="1">
+            <a:schemeClr val="dk1"/>
+          </a:fillRef>
+          <a:effectRef idx="0">
+            <a:schemeClr val="dk1"/>
+          </a:effectRef>
+          <a:fontRef idx="minor">
+            <a:schemeClr val="lt1"/>
+          </a:fontRef>
+        </p:style>
+        <p:txBody>
+          <a:bodyPr rtlCol="0" anchor="ctr"/>
+          <a:lstStyle/>
+          <a:p>
+            <a:pPr algn="ctr"/>
+            <a:endParaRPr lang="zh-CN" altLang="en-US"/>
+          </a:p>
+        </p:txBody>
+      </p:sp>
+      <p:sp>
+        <p:nvSpPr>
+          <p:cNvPr id="39" name="流程图: 接点 38">
+            <a:extLst>
+              <a:ext uri="{FF2B5EF4-FFF2-40B4-BE49-F238E27FC236}">
+                <a16:creationId xmlns:a16="http://schemas.microsoft.com/office/drawing/2014/main" id="{907D332F-8F3A-61E5-E0B0-0A8F4CB668E4}"/>
+              </a:ext>
+            </a:extLst>
+          </p:cNvPr>
+          <p:cNvSpPr/>
+          <p:nvPr/>
+        </p:nvSpPr>
+        <p:spPr>
+          <a:xfrm>
+            <a:off x="6299021" y="4150651"/>
+            <a:ext cx="60158" cy="68179"/>
+          </a:xfrm>
+          <a:prstGeom prst="flowChartConnector">
+            <a:avLst/>
+          </a:prstGeom>
+        </p:spPr>
+        <p:style>
+          <a:lnRef idx="2">
+            <a:schemeClr val="dk1">
+              <a:shade val="15000"/>
+            </a:schemeClr>
+          </a:lnRef>
+          <a:fillRef idx="1">
+            <a:schemeClr val="dk1"/>
+          </a:fillRef>
+          <a:effectRef idx="0">
+            <a:schemeClr val="dk1"/>
+          </a:effectRef>
+          <a:fontRef idx="minor">
+            <a:schemeClr val="lt1"/>
+          </a:fontRef>
+        </p:style>
+        <p:txBody>
+          <a:bodyPr rtlCol="0" anchor="ctr"/>
+          <a:lstStyle/>
+          <a:p>
+            <a:pPr algn="ctr"/>
+            <a:endParaRPr lang="zh-CN" altLang="en-US"/>
+          </a:p>
+        </p:txBody>
+      </p:sp>
     </p:spTree>
     <p:extLst>
       <p:ext uri="{BB962C8B-B14F-4D97-AF65-F5344CB8AC3E}">
-        <p14:creationId xmlns:p14="http://schemas.microsoft.com/office/powerpoint/2010/main" val="2552100656"/>
+        <p14:creationId xmlns:p14="http://schemas.microsoft.com/office/powerpoint/2010/main" val="2796279430"/>
       </p:ext>
     </p:extLst>
   </p:cSld>

</xml_diff>